<commit_message>
Complete v2 re-ranking (3 seeds x 5 arms); final deck
Paired over seeds 0-2, nuclei gained vs comparator (N=100 / N=200):
  fit vs raw image          +3 +5 +4 / +2 +4 +3   (all seeds)
  lr 0.05 vs 0.0016         -1 -5 -3 / -3 -4 -1   (hurts good seeds)
  lr 0.05 + cap vs base     -2 -5 -4 / -3 -3 -2   (combined recipe: no gain)
  cap vs none               0 0 0 / 0 -1 +1       (binds 2% of blobs)
  uniform vs 70% intensity  -4 -2 -1 / +3 0 +2    (+0.4 dB PSNR)
Raw detector with all 457 candidates finds 26/29; best single fit 23.

Co-Authored-By: Claude Opus 5.5 <noreply@anthropic.com>
</commit_message>
<xml_diff>
--- a/Tribolium_Gaussian_Splatting_v2.pptx
+++ b/Tribolium_Gaussian_Splatting_v2.pptx
@@ -770,7 +770,7 @@
           <a:lstStyle/>
           <a:p>
             <a:r>
-              <a:t>This is the check against a person's labels: 29 nuclei in a fruit-fly embryo crop. Every fit starts from the same detector candidates, so the only thing that differs is the fitting. We compare at the same number of detections, for example the top 100. The fit finds 14, the raw image 10. Downsampling to similar storage finds only 11 even in the top 200. So fitting sorts real nuclei higher. Honestly though: if the raw detector may use all 457 of its candidates, it finds 26, more than any fit. So this is better ranking, not a better detector. The size cap does nothing here, a higher learning rate made it worse, and uniform sampling ranked worse in the top 100. This is mean of 2 seeds.</a:t>
+              <a:t>This is the check against a person's labels: 29 nuclei in a fruit-fly embryo crop. Every fit starts from the same detector candidates, so the only thing that differs is the fitting. We compare at the same number of detections, for example the top 100. The fit finds 14, the raw image 10. Downsampling to similar storage finds only 11 even in the top 200. So fitting sorts real nuclei higher. Honestly though: if the raw detector may use all 457 of its candidates, it finds 26, more than any fit. So this is better ranking, not a better detector. The size cap does nothing here, a higher learning rate made it worse, and uniform sampling ranked worse in the top 100. This is mean of 3 seeds.</a:t>
             </a:r>
           </a:p>
           <a:p/>
@@ -2214,7 +2214,7 @@
                 <a:ea typeface="Calibri" pitchFamily="34" charset="-122"/>
                 <a:cs typeface="Calibri" pitchFamily="34" charset="-120"/>
               </a:rPr>
-              <a:t>On Tribolium, capping blob size kept more faint detector-found nuclei (+6 of 31, 4 regions, 1 seed) at no PSNR cost. On 29 human-labelled Drosophila nuclei, fitted blobs ranked nuclei better than the raw image at the same number of detections (14 vs 10 in the top 100, mean of 2 seeds).</a:t>
+              <a:t>On Tribolium, capping blob size kept more faint detector-found nuclei (+6 of 31, 4 regions, 1 seed) at no PSNR cost. On 29 human-labelled Drosophila nuclei, fitted blobs ranked nuclei better than the raw image at the same number of detections (14 vs 10 in the top 100, mean of 3 seeds).</a:t>
             </a:r>
             <a:endParaRPr lang="en-US" sz="1350" dirty="0"/>
           </a:p>
@@ -2315,7 +2315,7 @@
                 <a:ea typeface="Calibri" pitchFamily="34" charset="-122"/>
                 <a:cs typeface="Calibri" pitchFamily="34" charset="-120"/>
               </a:rPr>
-              <a:t>Our best-PSNR fit (uniform sampling, +0.4 dB) found fewer nuclei in the top 100 than the default fit (11 vs 14). A better picture is not a better nucleus list, so which metric you score decides which ideas survive.</a:t>
+              <a:t>Our best-PSNR fit (uniform sampling, +0.4 dB) found fewer nuclei in the top 100 than the default fit (11.7 vs 14). A better picture is not a better nucleus list, so which metric you score decides which ideas survive.</a:t>
             </a:r>
             <a:endParaRPr lang="en-US" sz="1350" dirty="0"/>
           </a:p>
@@ -3010,7 +3010,7 @@
                 </a:solidFill>
                 <a:latin typeface="Calibri"/>
               </a:rPr>
-              <a:t> · mean of 2 seeds</a:t>
+              <a:t> · mean of 3 seeds</a:t>
             </a:r>
           </a:p>
         </p:txBody>
@@ -3044,7 +3044,7 @@
                 </a:solidFill>
                 <a:latin typeface="Calibri"/>
               </a:rPr>
-              <a:t>Downsampled to similar storage (4,410 vs 5,500 numbers) it scores 17.9 dB vs 21.5 dB and finds 11/29 even in the top 200. But the raw detector, using all 457 candidates, finds 26/29, more than any fit. The size cap bound 2% of blobs and changed nothing; a high learning rate hurt; uniform sampling ranked worse in the top 100 (-3.0) and was unclear at 200 (+1.5). One nucleus = 3.4%; differences under ~3 nuclei are not resolvable.</a:t>
+              <a:t>Downsampled to similar storage (4,410 vs 5,500 numbers) it scores 17.9 dB vs 21.5 dB and finds 11/29 even in the top 200. But the raw detector, using all 457 candidates, finds 26/29, more than any fit. The size cap bound 2% of blobs and changed nothing; a high learning rate hurt; uniform sampling ranked worse in the top 100 (-2.3) and was unclear at 200 (+1.7). One nucleus = 3.4%; differences under ~3 nuclei are not resolvable.</a:t>
             </a:r>
           </a:p>
         </p:txBody>
@@ -6025,7 +6025,7 @@
                 <a:ea typeface="Calibri" pitchFamily="34" charset="-122"/>
                 <a:cs typeface="Calibri" pitchFamily="34" charset="-120"/>
               </a:rPr>
-              <a:t>Lets badly placed blobs travel to a nucleus. With good seeds it hurt (Drosophila: 21 → 17.5 of 29 in the top 200).</a:t>
+              <a:t>Lets badly placed blobs travel to a nucleus. With good seeds it hurt (Drosophila: 21 → 18.3 of 29 in the top 200).</a:t>
             </a:r>
             <a:endParaRPr lang="en-US" sz="1300" dirty="0"/>
           </a:p>
@@ -9708,7 +9708,7 @@
                 <a:ea typeface="Calibri" pitchFamily="34" charset="-122"/>
                 <a:cs typeface="Calibri" pitchFamily="34" charset="-120"/>
               </a:rPr>
-              <a:t>human-labelled Drosophila nuclei in the top 100 detections: fit vs raw image (mean of 2 seeds)</a:t>
+              <a:t>human-labelled Drosophila nuclei in the top 100 detections: fit vs raw image (mean of 3 seeds)</a:t>
             </a:r>
             <a:endParaRPr lang="en-US" sz="1300" dirty="0"/>
           </a:p>

</xml_diff>